<commit_message>
feat(ht26): update project presentation
</commit_message>
<xml_diff>
--- a/lectures/Project.pptx
+++ b/lectures/Project.pptx
@@ -356,7 +356,7 @@
           <a:p>
             <a:fld id="{4DDA272F-59C1-4644-BCBC-A6C8D77499CA}" type="datetimeFigureOut">
               <a:rPr lang="en-SE" smtClean="0"/>
-              <a:t>2025-11-19</a:t>
+              <a:t>2026-10-16</a:t>
             </a:fld>
             <a:endParaRPr lang="en-SE"/>
           </a:p>
@@ -673,6 +673,18 @@
               <a:t>The project is related to a disease called cystic fibrosis. </a:t>
             </a:r>
           </a:p>
+          <a:p>
+            <a:r>
+              <a:rPr lang="en-SE" dirty="0"/>
+              <a:t>For patients with cystic fibrosis their body produces </a:t>
+            </a:r>
+          </a:p>
+          <a:p>
+            <a:r>
+              <a:rPr lang="en-SE" dirty="0"/>
+              <a:t>CFTR modulators, for roughly 90% of patients, the medication can restore the protein function. </a:t>
+            </a:r>
+          </a:p>
         </p:txBody>
       </p:sp>
       <p:sp>
@@ -761,8 +773,11 @@
             </a:r>
             <a:r>
               <a:rPr lang="en-SE" dirty="0"/>
-              <a:t>ytoplasmic part is larger</a:t>
-            </a:r>
+              <a:t>ytoplasmic part is larger (as shown in the picture, lower part is cytoplasmic, upper is extracellular</a:t>
+            </a:r>
+          </a:p>
+          <a:p>
+            <a:endParaRPr lang="en-SE" dirty="0"/>
           </a:p>
         </p:txBody>
       </p:sp>
@@ -861,6 +876,21 @@
               <a:t>Non-synonymous mutation, means the amino acid will be changed caused by mutation.</a:t>
             </a:r>
           </a:p>
+          <a:p>
+            <a:r>
+              <a:rPr lang="en-SE" dirty="0"/>
+              <a:t>While a synonymous mutation, or slient mutation which changes a DNA letter without changing the amio acid due to redundency in the genetic code</a:t>
+            </a:r>
+          </a:p>
+          <a:p>
+            <a:endParaRPr lang="en-SE" dirty="0"/>
+          </a:p>
+          <a:p>
+            <a:r>
+              <a:rPr lang="en-SE" dirty="0"/>
+              <a:t>GC [A/U/C/G] -&gt; all 4 code for A (Alanine)</a:t>
+            </a:r>
+          </a:p>
         </p:txBody>
       </p:sp>
       <p:sp>
@@ -990,6 +1020,183 @@
 </file>
 
 <file path=ppt/notesSlides/notesSlide5.xml><?xml version="1.0" encoding="utf-8"?>
+<p:notes xmlns:a="http://schemas.openxmlformats.org/drawingml/2006/main" xmlns:r="http://schemas.openxmlformats.org/officeDocument/2006/relationships" xmlns:p="http://schemas.openxmlformats.org/presentationml/2006/main">
+  <p:cSld>
+    <p:spTree>
+      <p:nvGrpSpPr>
+        <p:cNvPr id="1" name=""/>
+        <p:cNvGrpSpPr/>
+        <p:nvPr/>
+      </p:nvGrpSpPr>
+      <p:grpSpPr>
+        <a:xfrm>
+          <a:off x="0" y="0"/>
+          <a:ext cx="0" cy="0"/>
+          <a:chOff x="0" y="0"/>
+          <a:chExt cx="0" cy="0"/>
+        </a:xfrm>
+      </p:grpSpPr>
+      <p:sp>
+        <p:nvSpPr>
+          <p:cNvPr id="2" name="Slide Image Placeholder 1"/>
+          <p:cNvSpPr>
+            <a:spLocks noGrp="1" noRot="1" noChangeAspect="1"/>
+          </p:cNvSpPr>
+          <p:nvPr>
+            <p:ph type="sldImg"/>
+          </p:nvPr>
+        </p:nvSpPr>
+        <p:spPr/>
+      </p:sp>
+      <p:sp>
+        <p:nvSpPr>
+          <p:cNvPr id="3" name="Notes Placeholder 2"/>
+          <p:cNvSpPr>
+            <a:spLocks noGrp="1"/>
+          </p:cNvSpPr>
+          <p:nvPr>
+            <p:ph type="body" idx="1"/>
+          </p:nvPr>
+        </p:nvSpPr>
+        <p:spPr/>
+        <p:txBody>
+          <a:bodyPr/>
+          <a:lstStyle/>
+          <a:p>
+            <a:r>
+              <a:rPr lang="en-SE" dirty="0"/>
+              <a:t>The strand indicate the orientation and directional reading of a gene relative to the reference genome assembly</a:t>
+            </a:r>
+          </a:p>
+        </p:txBody>
+      </p:sp>
+      <p:sp>
+        <p:nvSpPr>
+          <p:cNvPr id="4" name="Slide Number Placeholder 3"/>
+          <p:cNvSpPr>
+            <a:spLocks noGrp="1"/>
+          </p:cNvSpPr>
+          <p:nvPr>
+            <p:ph type="sldNum" sz="quarter" idx="5"/>
+          </p:nvPr>
+        </p:nvSpPr>
+        <p:spPr/>
+        <p:txBody>
+          <a:bodyPr/>
+          <a:lstStyle/>
+          <a:p>
+            <a:fld id="{CB8D2482-335E-734C-B42B-0D7FE3343100}" type="slidenum">
+              <a:rPr lang="en-SE" smtClean="0"/>
+              <a:t>10</a:t>
+            </a:fld>
+            <a:endParaRPr lang="en-SE"/>
+          </a:p>
+        </p:txBody>
+      </p:sp>
+    </p:spTree>
+    <p:extLst>
+      <p:ext uri="{BB962C8B-B14F-4D97-AF65-F5344CB8AC3E}">
+        <p14:creationId xmlns:p14="http://schemas.microsoft.com/office/powerpoint/2010/main" val="2907732900"/>
+      </p:ext>
+    </p:extLst>
+  </p:cSld>
+  <p:clrMapOvr>
+    <a:masterClrMapping/>
+  </p:clrMapOvr>
+</p:notes>
+</file>
+
+<file path=ppt/notesSlides/notesSlide6.xml><?xml version="1.0" encoding="utf-8"?>
+<p:notes xmlns:a="http://schemas.openxmlformats.org/drawingml/2006/main" xmlns:r="http://schemas.openxmlformats.org/officeDocument/2006/relationships" xmlns:p="http://schemas.openxmlformats.org/presentationml/2006/main">
+  <p:cSld>
+    <p:spTree>
+      <p:nvGrpSpPr>
+        <p:cNvPr id="1" name=""/>
+        <p:cNvGrpSpPr/>
+        <p:nvPr/>
+      </p:nvGrpSpPr>
+      <p:grpSpPr>
+        <a:xfrm>
+          <a:off x="0" y="0"/>
+          <a:ext cx="0" cy="0"/>
+          <a:chOff x="0" y="0"/>
+          <a:chExt cx="0" cy="0"/>
+        </a:xfrm>
+      </p:grpSpPr>
+      <p:sp>
+        <p:nvSpPr>
+          <p:cNvPr id="2" name="Slide Image Placeholder 1"/>
+          <p:cNvSpPr>
+            <a:spLocks noGrp="1" noRot="1" noChangeAspect="1"/>
+          </p:cNvSpPr>
+          <p:nvPr>
+            <p:ph type="sldImg"/>
+          </p:nvPr>
+        </p:nvSpPr>
+        <p:spPr/>
+      </p:sp>
+      <p:sp>
+        <p:nvSpPr>
+          <p:cNvPr id="3" name="Notes Placeholder 2"/>
+          <p:cNvSpPr>
+            <a:spLocks noGrp="1"/>
+          </p:cNvSpPr>
+          <p:nvPr>
+            <p:ph type="body" idx="1"/>
+          </p:nvPr>
+        </p:nvSpPr>
+        <p:spPr/>
+        <p:txBody>
+          <a:bodyPr/>
+          <a:lstStyle/>
+          <a:p>
+            <a:r>
+              <a:rPr lang="en-SE" dirty="0"/>
+              <a:t>The frame “.” means not applicable, because one can not directly start translating DNA sequence of a gene to amino acid sequence, instead one need to find the position of the start codon first.</a:t>
+            </a:r>
+          </a:p>
+          <a:p>
+            <a:endParaRPr lang="en-SE" dirty="0"/>
+          </a:p>
+        </p:txBody>
+      </p:sp>
+      <p:sp>
+        <p:nvSpPr>
+          <p:cNvPr id="4" name="Slide Number Placeholder 3"/>
+          <p:cNvSpPr>
+            <a:spLocks noGrp="1"/>
+          </p:cNvSpPr>
+          <p:nvPr>
+            <p:ph type="sldNum" sz="quarter" idx="5"/>
+          </p:nvPr>
+        </p:nvSpPr>
+        <p:spPr/>
+        <p:txBody>
+          <a:bodyPr/>
+          <a:lstStyle/>
+          <a:p>
+            <a:fld id="{CB8D2482-335E-734C-B42B-0D7FE3343100}" type="slidenum">
+              <a:rPr lang="en-SE" smtClean="0"/>
+              <a:t>12</a:t>
+            </a:fld>
+            <a:endParaRPr lang="en-SE"/>
+          </a:p>
+        </p:txBody>
+      </p:sp>
+    </p:spTree>
+    <p:extLst>
+      <p:ext uri="{BB962C8B-B14F-4D97-AF65-F5344CB8AC3E}">
+        <p14:creationId xmlns:p14="http://schemas.microsoft.com/office/powerpoint/2010/main" val="224020292"/>
+      </p:ext>
+    </p:extLst>
+  </p:cSld>
+  <p:clrMapOvr>
+    <a:masterClrMapping/>
+  </p:clrMapOvr>
+</p:notes>
+</file>
+
+<file path=ppt/notesSlides/notesSlide7.xml><?xml version="1.0" encoding="utf-8"?>
 <p:notes xmlns:a="http://schemas.openxmlformats.org/drawingml/2006/main" xmlns:r="http://schemas.openxmlformats.org/officeDocument/2006/relationships" xmlns:p="http://schemas.openxmlformats.org/presentationml/2006/main">
   <p:cSld>
     <p:spTree>
@@ -5075,7 +5282,9 @@
         </p:nvSpPr>
         <p:spPr/>
         <p:txBody>
-          <a:bodyPr/>
+          <a:bodyPr>
+            <a:normAutofit fontScale="92500" lnSpcReduction="10000"/>
+          </a:bodyPr>
           <a:lstStyle/>
           <a:p>
             <a:pPr marL="647693" indent="-342900" algn="l">
@@ -5128,7 +5337,7 @@
                 </a:solidFill>
                 <a:latin typeface="Calibri" panose="020F0502020204030204" pitchFamily="34" charset="0"/>
               </a:rPr>
-              <a:t>Work with </a:t>
+              <a:t>Work with Jupyter or any text editor or IDE (e.g., Spyder, </a:t>
             </a:r>
             <a:r>
               <a:rPr lang="en-GB" sz="2800" b="0" i="0" u="none" strike="noStrike" baseline="0" dirty="0" err="1">
@@ -5137,7 +5346,7 @@
                 </a:solidFill>
                 <a:latin typeface="Calibri" panose="020F0502020204030204" pitchFamily="34" charset="0"/>
               </a:rPr>
-              <a:t>Jupyter</a:t>
+              <a:t>VSCode</a:t>
             </a:r>
             <a:r>
               <a:rPr lang="en-GB" sz="2800" b="0" i="0" u="none" strike="noStrike" baseline="0" dirty="0">
@@ -5146,7 +5355,7 @@
                 </a:solidFill>
                 <a:latin typeface="Calibri" panose="020F0502020204030204" pitchFamily="34" charset="0"/>
               </a:rPr>
-              <a:t> or any text editor (e.g., Spyder, Sublime)</a:t>
+              <a:t>)</a:t>
             </a:r>
           </a:p>
           <a:p>
@@ -5193,7 +5402,67 @@
               </a:rPr>
               <a:t>Or use the discussion section in Canvas</a:t>
             </a:r>
-            <a:endParaRPr lang="en-GB" sz="2800" dirty="0"/>
+          </a:p>
+          <a:p>
+            <a:pPr marL="647693" indent="-342900" algn="l">
+              <a:buFont typeface="Courier New" panose="02070309020205020404" pitchFamily="49" charset="0"/>
+              <a:buChar char="o"/>
+            </a:pPr>
+            <a:r>
+              <a:rPr lang="en-GB" sz="2800" dirty="0">
+                <a:solidFill>
+                  <a:srgbClr val="000000"/>
+                </a:solidFill>
+                <a:latin typeface="Calibri" panose="020F0502020204030204" pitchFamily="34" charset="0"/>
+              </a:rPr>
+              <a:t>Don’t be too fast </a:t>
+            </a:r>
+            <a:r>
+              <a:rPr lang="en-GB" sz="2800" dirty="0">
+                <a:solidFill>
+                  <a:srgbClr val="000000"/>
+                </a:solidFill>
+                <a:latin typeface="Calibri" panose="020F0502020204030204" pitchFamily="34" charset="0"/>
+                <a:sym typeface="Wingdings" pitchFamily="2" charset="2"/>
+              </a:rPr>
+              <a:t></a:t>
+            </a:r>
+            <a:endParaRPr lang="en-GB" sz="2800" dirty="0">
+              <a:solidFill>
+                <a:srgbClr val="000000"/>
+              </a:solidFill>
+              <a:latin typeface="Calibri" panose="020F0502020204030204" pitchFamily="34" charset="0"/>
+            </a:endParaRPr>
+          </a:p>
+          <a:p>
+            <a:pPr marL="1257278" lvl="1" indent="-342900">
+              <a:buFont typeface="Courier New" panose="02070309020205020404" pitchFamily="49" charset="0"/>
+              <a:buChar char="o"/>
+            </a:pPr>
+            <a:r>
+              <a:rPr lang="en-GB" sz="2000" dirty="0"/>
+              <a:t>Day 1: &gt;| question 2</a:t>
+            </a:r>
+          </a:p>
+          <a:p>
+            <a:pPr marL="1257278" lvl="1" indent="-342900">
+              <a:buFont typeface="Courier New" panose="02070309020205020404" pitchFamily="49" charset="0"/>
+              <a:buChar char="o"/>
+            </a:pPr>
+            <a:r>
+              <a:rPr lang="en-GB" sz="2000" dirty="0"/>
+              <a:t>Day 2: &gt;| question 5</a:t>
+            </a:r>
+          </a:p>
+          <a:p>
+            <a:pPr marL="1257278" lvl="1" indent="-342900">
+              <a:buFont typeface="Courier New" panose="02070309020205020404" pitchFamily="49" charset="0"/>
+              <a:buChar char="o"/>
+            </a:pPr>
+            <a:r>
+              <a:rPr lang="en-GB" sz="2000" dirty="0"/>
+              <a:t>Day 3: The whole project</a:t>
+            </a:r>
           </a:p>
           <a:p>
             <a:pPr marL="647693" indent="-342900">
@@ -5201,7 +5470,7 @@
               <a:buChar char="o"/>
             </a:pPr>
             <a:r>
-              <a:rPr lang="en-SE" sz="3200" dirty="0"/>
+              <a:rPr lang="en-SE" sz="2800" dirty="0"/>
               <a:t>Find out more info at Canvas -&gt; Modules -&gt; Project</a:t>
             </a:r>
           </a:p>
@@ -5816,8 +6085,8 @@
         </p:nvSpPr>
         <p:spPr>
           <a:xfrm>
-            <a:off x="6509289" y="1294603"/>
-            <a:ext cx="5495440" cy="4765235"/>
+            <a:off x="6096000" y="1294603"/>
+            <a:ext cx="5908729" cy="4765235"/>
           </a:xfrm>
           <a:prstGeom prst="rect">
             <a:avLst/>
@@ -6122,7 +6391,27 @@
             </a:pPr>
             <a:r>
               <a:rPr lang="en-GB" sz="2400" dirty="0"/>
-              <a:t>No cure is available; only symptom management, such as airway clearance</a:t>
+              <a:t>No cure available</a:t>
+            </a:r>
+          </a:p>
+          <a:p>
+            <a:pPr marL="1257278" lvl="1" indent="-342900">
+              <a:buFont typeface="Courier New" panose="02070309020205020404" pitchFamily="49" charset="0"/>
+              <a:buChar char="o"/>
+            </a:pPr>
+            <a:r>
+              <a:rPr lang="en-GB" sz="1600" dirty="0"/>
+              <a:t>Previously only symptom management, such as airway clearance</a:t>
+            </a:r>
+          </a:p>
+          <a:p>
+            <a:pPr marL="1257278" lvl="1" indent="-342900">
+              <a:buFont typeface="Courier New" panose="02070309020205020404" pitchFamily="49" charset="0"/>
+              <a:buChar char="o"/>
+            </a:pPr>
+            <a:r>
+              <a:rPr lang="en-GB" sz="1600" dirty="0"/>
+              <a:t>Recent years developed modulator therapies. E.g. CFTR modulators, recover protein function for 90% of patients</a:t>
             </a:r>
           </a:p>
         </p:txBody>
@@ -6150,7 +6439,7 @@
         <p:spPr>
           <a:xfrm>
             <a:off x="660399" y="1690688"/>
-            <a:ext cx="5877168" cy="3291958"/>
+            <a:ext cx="5444027" cy="3049344"/>
           </a:xfrm>
           <a:prstGeom prst="rect">
             <a:avLst/>
@@ -6423,6 +6712,106 @@
           </a:p>
         </p:txBody>
       </p:sp>
+      <p:sp>
+        <p:nvSpPr>
+          <p:cNvPr id="6" name="TextBox 5">
+            <a:extLst>
+              <a:ext uri="{FF2B5EF4-FFF2-40B4-BE49-F238E27FC236}">
+                <a16:creationId xmlns:a16="http://schemas.microsoft.com/office/drawing/2014/main" id="{993BD3E6-0925-7719-7F55-8F6365DB539D}"/>
+              </a:ext>
+            </a:extLst>
+          </p:cNvPr>
+          <p:cNvSpPr txBox="1"/>
+          <p:nvPr/>
+        </p:nvSpPr>
+        <p:spPr>
+          <a:xfrm>
+            <a:off x="9573433" y="3987384"/>
+            <a:ext cx="1170513" cy="307777"/>
+          </a:xfrm>
+          <a:prstGeom prst="rect">
+            <a:avLst/>
+          </a:prstGeom>
+          <a:noFill/>
+        </p:spPr>
+        <p:txBody>
+          <a:bodyPr wrap="none" rtlCol="0">
+            <a:spAutoFit/>
+          </a:bodyPr>
+          <a:lstStyle/>
+          <a:p>
+            <a:r>
+              <a:rPr lang="en-SE" dirty="0">
+                <a:solidFill>
+                  <a:schemeClr val="accent4">
+                    <a:lumMod val="40000"/>
+                    <a:lumOff val="60000"/>
+                  </a:schemeClr>
+                </a:solidFill>
+              </a:rPr>
+              <a:t>Extracellular</a:t>
+            </a:r>
+            <a:endParaRPr lang="en-SE" dirty="0">
+              <a:solidFill>
+                <a:schemeClr val="accent1">
+                  <a:lumMod val="40000"/>
+                  <a:lumOff val="60000"/>
+                </a:schemeClr>
+              </a:solidFill>
+            </a:endParaRPr>
+          </a:p>
+        </p:txBody>
+      </p:sp>
+      <p:sp>
+        <p:nvSpPr>
+          <p:cNvPr id="8" name="TextBox 7">
+            <a:extLst>
+              <a:ext uri="{FF2B5EF4-FFF2-40B4-BE49-F238E27FC236}">
+                <a16:creationId xmlns:a16="http://schemas.microsoft.com/office/drawing/2014/main" id="{A446B1EB-3ED2-62A1-BBB3-22F65D5DE513}"/>
+              </a:ext>
+            </a:extLst>
+          </p:cNvPr>
+          <p:cNvSpPr txBox="1"/>
+          <p:nvPr/>
+        </p:nvSpPr>
+        <p:spPr>
+          <a:xfrm>
+            <a:off x="9710483" y="5105346"/>
+            <a:ext cx="1031051" cy="307777"/>
+          </a:xfrm>
+          <a:prstGeom prst="rect">
+            <a:avLst/>
+          </a:prstGeom>
+          <a:noFill/>
+        </p:spPr>
+        <p:txBody>
+          <a:bodyPr wrap="none" rtlCol="0">
+            <a:spAutoFit/>
+          </a:bodyPr>
+          <a:lstStyle/>
+          <a:p>
+            <a:r>
+              <a:rPr lang="en-SE" dirty="0">
+                <a:solidFill>
+                  <a:schemeClr val="accent4">
+                    <a:lumMod val="40000"/>
+                    <a:lumOff val="60000"/>
+                  </a:schemeClr>
+                </a:solidFill>
+              </a:rPr>
+              <a:t>Cytoplasm</a:t>
+            </a:r>
+            <a:endParaRPr lang="en-SE" dirty="0">
+              <a:solidFill>
+                <a:schemeClr val="accent1">
+                  <a:lumMod val="40000"/>
+                  <a:lumOff val="60000"/>
+                </a:schemeClr>
+              </a:solidFill>
+            </a:endParaRPr>
+          </a:p>
+        </p:txBody>
+      </p:sp>
     </p:spTree>
     <p:extLst>
       <p:ext uri="{BB962C8B-B14F-4D97-AF65-F5344CB8AC3E}">
@@ -6628,7 +7017,7 @@
           <a:p>
             <a:r>
               <a:rPr lang="en-GB" sz="2800" b="1" dirty="0"/>
-              <a:t>Write a Python program that:</a:t>
+              <a:t>Write Python program(s) that:</a:t>
             </a:r>
           </a:p>
           <a:p>
@@ -6658,11 +7047,11 @@
             </a:pPr>
             <a:r>
               <a:rPr lang="en-GB" sz="2800" dirty="0"/>
-              <a:t>Determine if one or more patients have a premature stop codon, that is, </a:t>
+              <a:t>Determine if one or more patients (from DNA sequences of 5 patients) have a premature stop codon, that is, </a:t>
             </a:r>
             <a:r>
               <a:rPr lang="en-GB" sz="2800" b="1" dirty="0"/>
-              <a:t>which shortened amino acid sequence</a:t>
+              <a:t>with shortened amino acid sequence</a:t>
             </a:r>
           </a:p>
           <a:p>

</xml_diff>